<commit_message>
Show row-count feedback for both normal completion and timeout
</commit_message>
<xml_diff>
--- a/design/patent-timeout-feedback-figures/pptx/fig2-system.pptx
+++ b/design/patent-timeout-feedback-figures/pptx/fig2-system.pptx
@@ -2,13 +2,13 @@
 <file path=ppt/presentation.xml><?xml version="1.0" encoding="utf-8"?>
 <p:presentation xmlns:p="http://schemas.openxmlformats.org/presentationml/2006/main">
   <p:sldMasterIdLst>
-    <p:sldMasterId xmlns:r="http://schemas.openxmlformats.org/officeDocument/2006/relationships" id="2147483648" r:id="R01eecab75a8f4e82"/>
+    <p:sldMasterId xmlns:r="http://schemas.openxmlformats.org/officeDocument/2006/relationships" id="2147483648" r:id="R521af6439a7f4574"/>
   </p:sldMasterIdLst>
   <p:notesMasterIdLst>
-    <p:notesMasterId xmlns:r="http://schemas.openxmlformats.org/officeDocument/2006/relationships" r:id="R0d4aea8d6ab44678"/>
+    <p:notesMasterId xmlns:r="http://schemas.openxmlformats.org/officeDocument/2006/relationships" r:id="R0a86282494bb4997"/>
   </p:notesMasterIdLst>
   <p:sldIdLst>
-    <p:sldId xmlns:r="http://schemas.openxmlformats.org/officeDocument/2006/relationships" id="256" r:id="R21848091e480463a"/>
+    <p:sldId xmlns:r="http://schemas.openxmlformats.org/officeDocument/2006/relationships" id="256" r:id="R9ab8491f1add4218"/>
   </p:sldIdLst>
   <p:sldSz cx="12192000" cy="6858000"/>
   <p:notesSz cx="6858000" cy="9144000"/>
@@ -2315,12 +2315,12 @@
   </p:cSld>
   <p:clrMap bg1="lt1" tx1="dk1" bg2="lt2" tx2="dk2" accent1="accent1" accent2="accent2" accent3="accent3" accent4="accent4" accent5="accent5" accent6="accent6" hlink="hlink" folHlink="folHlink"/>
   <p:sldLayoutIdLst>
-    <p:sldLayoutId xmlns:r="http://schemas.openxmlformats.org/officeDocument/2006/relationships" id="2147483649" r:id="R787cb6c7006048bb"/>
-    <p:sldLayoutId xmlns:r="http://schemas.openxmlformats.org/officeDocument/2006/relationships" id="2147483650" r:id="R4a0a6fb5a05749e8"/>
-    <p:sldLayoutId xmlns:r="http://schemas.openxmlformats.org/officeDocument/2006/relationships" id="2147483651" r:id="Rd8cd79d52caa40e7"/>
-    <p:sldLayoutId xmlns:r="http://schemas.openxmlformats.org/officeDocument/2006/relationships" id="2147483652" r:id="R71d352dd55024e62"/>
-    <p:sldLayoutId xmlns:r="http://schemas.openxmlformats.org/officeDocument/2006/relationships" id="2147483653" r:id="R836ebd94c25d4d8b"/>
-    <p:sldLayoutId xmlns:r="http://schemas.openxmlformats.org/officeDocument/2006/relationships" id="2147483654" r:id="R4778cf94f3ac43fc"/>
+    <p:sldLayoutId xmlns:r="http://schemas.openxmlformats.org/officeDocument/2006/relationships" id="2147483649" r:id="R9014bbe43c9a492b"/>
+    <p:sldLayoutId xmlns:r="http://schemas.openxmlformats.org/officeDocument/2006/relationships" id="2147483650" r:id="Rfd17851b9cad4dc3"/>
+    <p:sldLayoutId xmlns:r="http://schemas.openxmlformats.org/officeDocument/2006/relationships" id="2147483651" r:id="Rc6e4af996e2d4fe8"/>
+    <p:sldLayoutId xmlns:r="http://schemas.openxmlformats.org/officeDocument/2006/relationships" id="2147483652" r:id="R3b82a037bbf0447a"/>
+    <p:sldLayoutId xmlns:r="http://schemas.openxmlformats.org/officeDocument/2006/relationships" id="2147483653" r:id="Rbb3a5163889a4411"/>
+    <p:sldLayoutId xmlns:r="http://schemas.openxmlformats.org/officeDocument/2006/relationships" id="2147483654" r:id="R605cb312d1eb43e3"/>
   </p:sldLayoutIdLst>
   <p:txStyles>
     <p:titleStyle>
@@ -4263,7 +4263,7 @@
         <p:spPr>
           <a:xfrm xmlns:a="http://schemas.openxmlformats.org/drawingml/2006/main">
             <a:off x="9610193" y="2924175"/>
-            <a:ext cx="0" cy="142875"/>
+            <a:ext cx="2381250" cy="142875"/>
           </a:xfrm>
           <a:prstGeom xmlns:a="http://schemas.openxmlformats.org/drawingml/2006/main" prst="rect">
             <a:avLst/>
@@ -4314,7 +4314,7 @@
                 <a:ea typeface="Microsoft YaHei"/>
                 <a:cs typeface="Microsoft YaHei"/>
               </a:rPr>
-              <a:t>正常结束：执行时间</a:t>
+              <a:t>正常完成：执行时间</a:t>
             </a:r>
           </a:p>
         </p:txBody>
@@ -5262,7 +5262,7 @@
         <p:spPr>
           <a:xfrm xmlns:a="http://schemas.openxmlformats.org/drawingml/2006/main">
             <a:off x="3415984" y="4410075"/>
-            <a:ext cx="0" cy="142875"/>
+            <a:ext cx="3048000" cy="142875"/>
           </a:xfrm>
           <a:prstGeom xmlns:a="http://schemas.openxmlformats.org/drawingml/2006/main" prst="rect">
             <a:avLst/>
@@ -5313,7 +5313,7 @@
                 <a:ea typeface="Microsoft YaHei"/>
                 <a:cs typeface="Microsoft YaHei"/>
               </a:rPr>
-              <a:t>绿色：超时节点反馈路径</a:t>
+              <a:t>绿色：算子行数反馈路径</a:t>
             </a:r>
           </a:p>
         </p:txBody>
@@ -5459,6 +5459,166 @@
                 <a:cs typeface="Microsoft YaHei"/>
               </a:rPr>
               <a:t>生成第 i+1 轮候选</a:t>
+            </a:r>
+          </a:p>
+        </p:txBody>
+      </p:sp>
+      <p:sp>
+        <p:nvSpPr>
+          <p:cNvPr id="54" name="normal-completion-row-feedback">
+            <a:extLst xmlns:a="http://schemas.openxmlformats.org/drawingml/2006/main">
+              <a:ext uri="{FF2B5EF4-FFF2-40B4-BE49-F238E27FC236}">
+                <a16:creationId xmlns:a16="http://schemas.microsoft.com/office/drawing/2014/main" id="{26C4175D-251F-469F-8F15-3BB49395F7FD}"/>
+              </a:ext>
+            </a:extLst>
+          </p:cNvPr>
+          <p:cNvSpPr>
+            <a:spLocks xmlns:a="http://schemas.openxmlformats.org/drawingml/2006/main" noGrp="1"/>
+          </p:cNvSpPr>
+          <p:nvPr/>
+        </p:nvSpPr>
+        <p:spPr>
+          <a:xfrm xmlns:a="http://schemas.openxmlformats.org/drawingml/2006/main">
+            <a:off x="6191250" y="3493770"/>
+            <a:ext cx="2152650" cy="335280"/>
+          </a:xfrm>
+          <a:custGeom xmlns:a="http://schemas.openxmlformats.org/drawingml/2006/main">
+            <a:pathLst>
+              <a:path w="2152650" h="335280">
+                <a:moveTo>
+                  <a:pt x="2152650" y="0"/>
+                </a:moveTo>
+                <a:lnTo>
+                  <a:pt x="2152650" y="287655"/>
+                </a:lnTo>
+                <a:lnTo>
+                  <a:pt x="0" y="287655"/>
+                </a:lnTo>
+                <a:lnTo>
+                  <a:pt x="0" y="335280"/>
+                </a:lnTo>
+              </a:path>
+            </a:pathLst>
+          </a:custGeom>
+          <a:noFill xmlns:a="http://schemas.openxmlformats.org/drawingml/2006/main"/>
+          <a:ln xmlns:a="http://schemas.openxmlformats.org/drawingml/2006/main" w="23813">
+            <a:solidFill>
+              <a:srgbClr val="1D7B74"/>
+            </a:solidFill>
+          </a:ln>
+        </p:spPr>
+      </p:sp>
+      <p:sp>
+        <p:nvSpPr>
+          <p:cNvPr id="55" name="normal-completion-row-feedback-arrow">
+            <a:extLst xmlns:a="http://schemas.openxmlformats.org/drawingml/2006/main">
+              <a:ext uri="{FF2B5EF4-FFF2-40B4-BE49-F238E27FC236}">
+                <a16:creationId xmlns:a16="http://schemas.microsoft.com/office/drawing/2014/main" id="{3433B32A-D0B7-4029-BE11-9A6C092076DB}"/>
+              </a:ext>
+            </a:extLst>
+          </p:cNvPr>
+          <p:cNvSpPr>
+            <a:spLocks xmlns:a="http://schemas.openxmlformats.org/drawingml/2006/main" noGrp="1"/>
+          </p:cNvSpPr>
+          <p:nvPr/>
+        </p:nvSpPr>
+        <p:spPr>
+          <a:xfrm xmlns:a="http://schemas.openxmlformats.org/drawingml/2006/main">
+            <a:off x="6148388" y="3776663"/>
+            <a:ext cx="85725" cy="52388"/>
+          </a:xfrm>
+          <a:custGeom xmlns:a="http://schemas.openxmlformats.org/drawingml/2006/main">
+            <a:pathLst>
+              <a:path w="85725" h="52388">
+                <a:moveTo>
+                  <a:pt x="42863" y="52388"/>
+                </a:moveTo>
+                <a:lnTo>
+                  <a:pt x="0" y="0"/>
+                </a:lnTo>
+                <a:lnTo>
+                  <a:pt x="85725" y="0"/>
+                </a:lnTo>
+                <a:close/>
+              </a:path>
+            </a:pathLst>
+          </a:custGeom>
+          <a:solidFill xmlns:a="http://schemas.openxmlformats.org/drawingml/2006/main">
+            <a:srgbClr val="1D7B74"/>
+          </a:solidFill>
+          <a:ln xmlns:a="http://schemas.openxmlformats.org/drawingml/2006/main" w="0">
+            <a:noFill/>
+          </a:ln>
+        </p:spPr>
+      </p:sp>
+      <p:sp>
+        <p:nvSpPr>
+          <p:cNvPr id="56" name="normal-completion-statistics-label">
+            <a:extLst xmlns:a="http://schemas.openxmlformats.org/drawingml/2006/main">
+              <a:ext uri="{FF2B5EF4-FFF2-40B4-BE49-F238E27FC236}">
+                <a16:creationId xmlns:a16="http://schemas.microsoft.com/office/drawing/2014/main" id="{BB58F9B4-901D-4F7C-BAE3-978F87404301}"/>
+              </a:ext>
+            </a:extLst>
+          </p:cNvPr>
+          <p:cNvSpPr>
+            <a:spLocks xmlns:a="http://schemas.openxmlformats.org/drawingml/2006/main" noGrp="1"/>
+          </p:cNvSpPr>
+          <p:nvPr/>
+        </p:nvSpPr>
+        <p:spPr>
+          <a:xfrm xmlns:a="http://schemas.openxmlformats.org/drawingml/2006/main">
+            <a:off x="6667500" y="3600450"/>
+            <a:ext cx="1619250" cy="152400"/>
+          </a:xfrm>
+          <a:prstGeom xmlns:a="http://schemas.openxmlformats.org/drawingml/2006/main" prst="rect">
+            <a:avLst/>
+          </a:prstGeom>
+          <a:noFill xmlns:a="http://schemas.openxmlformats.org/drawingml/2006/main"/>
+          <a:ln xmlns:a="http://schemas.openxmlformats.org/drawingml/2006/main" w="0">
+            <a:noFill/>
+          </a:ln>
+        </p:spPr>
+        <p:txBody>
+          <a:bodyPr xmlns:a="http://schemas.openxmlformats.org/drawingml/2006/main" wrap="none" lIns="0" tIns="0" rIns="0" bIns="0" anchor="t">
+            <a:noAutofit/>
+          </a:bodyPr>
+          <a:lstStyle xmlns:a="http://schemas.openxmlformats.org/drawingml/2006/main">
+            <a:defPPr algn="l">
+              <a:defRPr sz="900" b="0">
+                <a:solidFill>
+                  <a:srgbClr val="1D7B74"/>
+                </a:solidFill>
+                <a:latin typeface="Microsoft YaHei"/>
+                <a:ea typeface="Microsoft YaHei"/>
+                <a:cs typeface="Microsoft YaHei"/>
+              </a:defRPr>
+            </a:defPPr>
+          </a:lstStyle>
+          <a:p xmlns:a="http://schemas.openxmlformats.org/drawingml/2006/main">
+            <a:pPr algn="l">
+              <a:lnSpc>
+                <a:spcPct val="100000"/>
+              </a:lnSpc>
+              <a:buNone/>
+              <a:defRPr sz="900" b="0">
+                <a:solidFill>
+                  <a:srgbClr val="1D7B74"/>
+                </a:solidFill>
+                <a:latin typeface="Microsoft YaHei"/>
+                <a:ea typeface="Microsoft YaHei"/>
+                <a:cs typeface="Microsoft YaHei"/>
+              </a:defRPr>
+            </a:pPr>
+            <a:r>
+              <a:rPr sz="900" b="0">
+                <a:solidFill>
+                  <a:srgbClr val="1D7B74"/>
+                </a:solidFill>
+                <a:latin typeface="Microsoft YaHei"/>
+                <a:ea typeface="Microsoft YaHei"/>
+                <a:cs typeface="Microsoft YaHei"/>
+              </a:rPr>
+              <a:t>正常完成：算子统计</a:t>
             </a:r>
           </a:p>
         </p:txBody>

</xml_diff>